<commit_message>
Update deck and proposal draft to 26 Oct, add research ideas
- Deck: cite the official Reservoir Status page, add Cyclone Ditwah, new speaker notes and a centred QR caption; slides PDF refreshed
- Proposal: 26 Oct draft with the research fixes; the PDF build now puts the map above Table 2 and sorts the references
- Research: ideas to strengthen and widen the scope, each with a source
- README: daily data is now saved by water-data-logger; link to the Global Water Watch archive
</commit_message>
<xml_diff>
--- a/swot-tank-tracker/presentation/SWOT Tank Water Tracker - proposal talk.pptx
+++ b/swot-tank-tracker/presentation/SWOT Tank Water Tracker - proposal talk.pptx
@@ -121,35 +121,35 @@
   <p:extLst>
     <p:ext uri="{521415D9-36F7-43E2-AB2F-B90AF26B5E84}">
       <p14:sectionLst xmlns:p14="http://schemas.microsoft.com/office/powerpoint/2010/main">
-        <p14:section name="Introduction" id="{32f1d99a-2a4f-5797-8544-9ce4c1c0c0e0}">
+        <p14:section name="Introduction" id="{2d7b9b74-1428-159d-8768-279288159530}">
           <p14:sldIdLst>
             <p14:sldId id="256"/>
             <p14:sldId id="257"/>
             <p14:sldId id="258"/>
           </p14:sldIdLst>
         </p14:section>
-        <p14:section name="The satellites" id="{c44070f2-b8b4-f883-4518-aac41dcc1b86}">
+        <p14:section name="The satellites" id="{709ecc64-5c6a-9a75-6119-f5c2acf012c6}">
           <p14:sldIdLst>
             <p14:sldId id="259"/>
             <p14:sldId id="260"/>
             <p14:sldId id="261"/>
           </p14:sldIdLst>
         </p14:section>
-        <p14:section name="Study and method" id="{10a038ba-711f-c376-4077-60ebbabe523c}">
+        <p14:section name="Study and method" id="{64129a62-c53e-d91d-f334-cd5ac7e92511}">
           <p14:sldIdLst>
             <p14:sldId id="262"/>
             <p14:sldId id="263"/>
             <p14:sldId id="264"/>
           </p14:sldIdLst>
         </p14:section>
-        <p14:section name="Evidence" id="{450f62bd-e427-b531-e4ea-8222e71af15f}">
+        <p14:section name="Evidence" id="{529e9dcb-76bf-cb10-0584-8bd226e0ef36}">
           <p14:sldIdLst>
             <p14:sldId id="265"/>
             <p14:sldId id="266"/>
             <p14:sldId id="267"/>
           </p14:sldIdLst>
         </p14:section>
-        <p14:section name="Plan" id="{9573e782-508d-c25c-f379-5351de350645}">
+        <p14:section name="Plan" id="{3237a4d3-488c-9a7d-5d16-a6c33cf13ab2}">
           <p14:sldIdLst>
             <p14:sldId id="268"/>
             <p14:sldId id="269"/>
@@ -4439,7 +4439,7 @@
         <p:spPr>
           <a:xfrm>
             <a:off x="548640" y="1143000"/>
-            <a:ext cx="11094415" cy="365760"/>
+            <a:ext cx="11094415" cy="548640"/>
           </a:xfrm>
           <a:prstGeom prst="rect">
             <a:avLst/>
@@ -4461,6 +4461,20 @@
                 </a:solidFill>
               </a:rPr>
               <a:t>Monthly average of best-quality readings, in metres above each reservoir's lowest month.</a:t>
+            </a:r>
+            <a:endParaRPr lang="en-US" sz="1400" dirty="0"/>
+          </a:p>
+          <a:p>
+            <a:pPr indent="0" marL="0">
+              <a:buNone/>
+            </a:pPr>
+            <a:r>
+              <a:rPr lang="en-US" sz="1400" b="1" dirty="0">
+                <a:solidFill>
+                  <a:schemeClr val="accent2"/>
+                </a:solidFill>
+              </a:rPr>
+              <a:t>The sharp rise at the end of 2025 is Cyclone Ditwah.</a:t>
             </a:r>
             <a:endParaRPr lang="en-US" sz="1400" dirty="0"/>
           </a:p>
@@ -9156,8 +9170,8 @@
         </p:nvSpPr>
         <p:spPr>
           <a:xfrm>
-            <a:off x="8778240" y="4800600"/>
-            <a:ext cx="2862072" cy="731520"/>
+            <a:off x="9098280" y="4800600"/>
+            <a:ext cx="2542032" cy="731520"/>
           </a:xfrm>
           <a:prstGeom prst="rect">
             <a:avLst/>
@@ -9169,25 +9183,25 @@
           <a:bodyPr wrap="square" lIns="0" tIns="0" rIns="0" bIns="0" rtlCol="0" anchor="t"/>
           <a:lstStyle/>
           <a:p>
-            <a:pPr indent="0" marL="0">
-              <a:buNone/>
-            </a:pPr>
-            <a:r>
-              <a:rPr lang="en-US" sz="1250" dirty="0">
+            <a:pPr algn="ctr" indent="0" marL="0">
+              <a:buNone/>
+            </a:pPr>
+            <a:r>
+              <a:rPr lang="en-US" sz="1200" dirty="0">
                 <a:solidFill>
                   <a:srgbClr val="C9D6DE"/>
                 </a:solidFill>
               </a:rPr>
               <a:t>See SWOT readings for any lake:</a:t>
             </a:r>
-            <a:endParaRPr lang="en-US" sz="1250" dirty="0"/>
-          </a:p>
-          <a:p>
-            <a:pPr indent="0" marL="0">
-              <a:buNone/>
-            </a:pPr>
-            <a:r>
-              <a:rPr lang="en-US" sz="1250" b="1" u="sng" dirty="0">
+            <a:endParaRPr lang="en-US" sz="1200" dirty="0"/>
+          </a:p>
+          <a:p>
+            <a:pPr algn="ctr" indent="0" marL="0">
+              <a:buNone/>
+            </a:pPr>
+            <a:r>
+              <a:rPr lang="en-US" sz="1200" b="1" u="sng" dirty="0">
                 <a:solidFill>
                   <a:schemeClr val="accent5"/>
                 </a:solidFill>
@@ -9201,7 +9215,7 @@
               </a:rPr>
               <a:t>SWOT Lake and River Explorer</a:t>
             </a:r>
-            <a:endParaRPr lang="en-US" sz="1250" dirty="0"/>
+            <a:endParaRPr lang="en-US" sz="1200" dirty="0"/>
           </a:p>
         </p:txBody>
       </p:sp>
@@ -9529,7 +9543,7 @@
                   <a:schemeClr val="accent6"/>
                 </a:solidFill>
               </a:rPr>
-              <a:t>Irrigation Department daily sheet, 25 Oct 2026</a:t>
+              <a:t>Irrigation Department, Reservoir Status, 25 Oct 2026</a:t>
             </a:r>
             <a:endParaRPr lang="en-US" sz="1050" dirty="0"/>
           </a:p>
@@ -9654,8 +9668,8 @@
         </p:nvSpPr>
         <p:spPr>
           <a:xfrm>
-            <a:off x="548640" y="5440680"/>
-            <a:ext cx="6263640" cy="685800"/>
+            <a:off x="548640" y="5029200"/>
+            <a:ext cx="6263640" cy="566928"/>
           </a:xfrm>
           <a:prstGeom prst="rect">
             <a:avLst/>
@@ -9679,12 +9693,59 @@
               <a:t>A shallow tank and a deep tank of the same size hold very different amounts of water.</a:t>
             </a:r>
             <a:endParaRPr lang="en-US" sz="1600" dirty="0"/>
+          </a:p>
+        </p:txBody>
+      </p:sp>
+      <p:sp>
+        <p:nvSpPr>
+          <p:cNvPr id="13" name="Text 11"/>
+          <p:cNvSpPr txBox="1"/>
+          <p:nvPr/>
+        </p:nvSpPr>
+        <p:spPr>
+          <a:xfrm>
+            <a:off x="548640" y="5715000"/>
+            <a:ext cx="6263640" cy="457200"/>
+          </a:xfrm>
+          <a:prstGeom prst="rect">
+            <a:avLst/>
+          </a:prstGeom>
+          <a:noFill/>
+          <a:ln/>
+        </p:spPr>
+        <p:txBody>
+          <a:bodyPr wrap="square" lIns="0" tIns="0" rIns="0" bIns="0" rtlCol="0" anchor="t"/>
+          <a:lstStyle/>
+          <a:p>
+            <a:pPr indent="0" marL="0">
+              <a:buNone/>
+            </a:pPr>
+            <a:r>
+              <a:rPr lang="en-US" sz="1300" b="1" dirty="0">
+                <a:solidFill>
+                  <a:schemeClr val="accent2"/>
+                </a:solidFill>
+              </a:rPr>
+              <a:t>Cyclone Ditwah, Nov 2025: </a:t>
+            </a:r>
+            <a:pPr indent="0" marL="0">
+              <a:buNone/>
+            </a:pPr>
+            <a:r>
+              <a:rPr lang="en-US" sz="1300" dirty="0">
+                <a:solidFill>
+                  <a:schemeClr val="tx1"/>
+                </a:solidFill>
+              </a:rPr>
+              <a:t>1,160 small tanks damaged (Department of Agrarian Development)</a:t>
+            </a:r>
+            <a:endParaRPr lang="en-US" sz="1300" dirty="0"/>
           </a:p>
         </p:txBody>
       </p:sp>
       <p:pic>
         <p:nvPicPr>
-          <p:cNvPr id="13" name="Image 0" descr="Satellite image of the study area with every mapped tank shown in blue">    </p:cNvPr>
+          <p:cNvPr id="14" name="Image 0" descr="Satellite image of the study area with every mapped tank shown in blue">    </p:cNvPr>
           <p:cNvPicPr>
             <a:picLocks noChangeAspect="1"/>
           </p:cNvPicPr>
@@ -9708,7 +9769,7 @@
       </p:pic>
       <p:sp>
         <p:nvSpPr>
-          <p:cNvPr id="14" name="image caption"/>
+          <p:cNvPr id="15" name="image caption"/>
           <p:cNvSpPr/>
           <p:nvPr/>
         </p:nvSpPr>
@@ -9737,7 +9798,7 @@
       </p:sp>
       <p:sp>
         <p:nvSpPr>
-          <p:cNvPr id="15" name="Text 12"/>
+          <p:cNvPr id="16" name="Text 13"/>
           <p:cNvSpPr txBox="1"/>
           <p:nvPr/>
         </p:nvSpPr>

</xml_diff>

<commit_message>
New plan: B turns SWOT height and water area into % full (RQ2 and RQ3), C forecasts and runs the system (RQ4)
Proposal draft, the talk (no speaker notes) and its builder (no notes) updated.
</commit_message>
<xml_diff>
--- a/swot-tank-tracker/presentation/SWOT Tank Water Tracker - proposal talk.pptx
+++ b/swot-tank-tracker/presentation/SWOT Tank Water Tracker - proposal talk.pptx
@@ -127,7 +127,7 @@
   <p:extLst>
     <p:ext uri="{521415D9-36F7-43E2-AB2F-B90AF26B5E84}">
       <p14:sectionLst xmlns:p14="http://schemas.microsoft.com/office/powerpoint/2010/main">
-        <p14:section name="Introduction" id="{58285f1d-be3d-a84f-afed-f8c45c056ebf}">
+        <p14:section name="Introduction" id="{3f6419a0-d7b3-caf8-cefb-36542fd2a945}">
           <p14:sldIdLst>
             <p14:sldId id="256"/>
             <p14:sldId id="257"/>
@@ -135,28 +135,28 @@
             <p14:sldId id="259"/>
           </p14:sldIdLst>
         </p14:section>
-        <p14:section name="The satellites" id="{36f4b2e8-185e-836f-ec15-7966a2d9b702}">
+        <p14:section name="The satellites" id="{6341b1b3-8d9f-6374-326b-68f42ca05fc6}">
           <p14:sldIdLst>
             <p14:sldId id="260"/>
             <p14:sldId id="261"/>
             <p14:sldId id="262"/>
           </p14:sldIdLst>
         </p14:section>
-        <p14:section name="Study and method" id="{605ca566-8139-aeb0-cd9a-e187ddfe1808}">
+        <p14:section name="Study and method" id="{cec30c08-7fc8-29b7-d9d6-6d1ed1a64b5b}">
           <p14:sldIdLst>
             <p14:sldId id="263"/>
             <p14:sldId id="264"/>
             <p14:sldId id="265"/>
           </p14:sldIdLst>
         </p14:section>
-        <p14:section name="Evidence" id="{43a5f231-0145-a545-a9d9-e158ade9b0b2}">
+        <p14:section name="Evidence" id="{d575cb99-b694-f74a-3146-9f6fea1ed83d}">
           <p14:sldIdLst>
             <p14:sldId id="266"/>
             <p14:sldId id="267"/>
             <p14:sldId id="268"/>
           </p14:sldIdLst>
         </p14:section>
-        <p14:section name="Plan" id="{a4f3036b-b7c9-19e6-eefd-33bf7911b125}">
+        <p14:section name="Plan" id="{370aa6a0-fe83-f063-c81c-f39cb5cfa854}">
           <p14:sldIdLst>
             <p14:sldId id="269"/>
             <p14:sldId id="270"/>
@@ -8094,7 +8094,7 @@
                   <a:schemeClr val="tx1"/>
                 </a:solidFill>
               </a:rPr>
-              <a:t>How accurate is SWOT on reservoirs and village tanks, and can a learned model tell which readings to trust better than SWOT's own flags?</a:t>
+              <a:t>How accurate is SWOT on reservoirs and village tanks, and how many "suspect" readings can a learned screen keep?</a:t>
             </a:r>
             <a:endParaRPr lang="en-US" sz="1600" dirty="0"/>
           </a:p>
@@ -8130,7 +8130,7 @@
                   <a:schemeClr val="accent6"/>
                 </a:solidFill>
               </a:rPr>
-              <a:t>Measured by error in cm against gauges, on reservoirs the model never saw</a:t>
+              <a:t>Measured by error in cm against gauges, on reservoirs the screen never saw</a:t>
             </a:r>
             <a:endParaRPr lang="en-US" sz="1150" dirty="0"/>
           </a:p>
@@ -8257,7 +8257,7 @@
                   <a:schemeClr val="tx1"/>
                 </a:solidFill>
               </a:rPr>
-              <a:t>Does AI water area plus SWOT height give storage close to official and measured values?</a:t>
+              <a:t>Can a model trained on about 100 gauged reservoirs turn SWOT height and water area into % full, for tanks it never saw?</a:t>
             </a:r>
             <a:endParaRPr lang="en-US" sz="1600" dirty="0"/>
           </a:p>
@@ -8293,7 +8293,7 @@
                   <a:schemeClr val="accent6"/>
                 </a:solidFill>
               </a:rPr>
-              <a:t>Measured by error as a % of capacity</a:t>
+              <a:t>Measured by error in % of capacity, on reservoirs it never saw</a:t>
             </a:r>
             <a:endParaRPr lang="en-US" sz="1150" dirty="0"/>
           </a:p>
@@ -8600,7 +8600,7 @@
                   <a:schemeClr val="accent6"/>
                 </a:solidFill>
               </a:rPr>
-              <a:t>Each of us owns a research question from start to finish, and trains one model for it.</a:t>
+              <a:t>Three models in one chain: A finds where the water is, B how much there is, and C what comes next.</a:t>
             </a:r>
             <a:endParaRPr lang="en-US" sz="1400" dirty="0"/>
           </a:p>
@@ -8967,7 +8967,7 @@
                   <a:schemeClr val="tx1"/>
                 </a:solidFill>
               </a:rPr>
-              <a:t>water maps for all tanks</a:t>
+              <a:t>the water area of every tank</a:t>
             </a:r>
             <a:endParaRPr lang="en-US" sz="1250" dirty="0"/>
           </a:p>
@@ -9125,7 +9125,7 @@
                 <a:ea typeface="+mj-lt" pitchFamily="34" charset="-122"/>
                 <a:cs typeface="+mj-lt" pitchFamily="34" charset="-120"/>
               </a:rPr>
-              <a:t>SWOT and gauges</a:t>
+              <a:t>SWOT and storage</a:t>
             </a:r>
             <a:endParaRPr lang="en-US" sz="1900" dirty="0"/>
           </a:p>
@@ -9196,7 +9196,70 @@
       </p:sp>
       <p:sp>
         <p:nvSpPr>
-          <p:cNvPr id="21" name="Text 17"/>
+          <p:cNvPr id="21" name="RQ3"/>
+          <p:cNvSpPr/>
+          <p:nvPr/>
+        </p:nvSpPr>
+        <p:spPr>
+          <a:xfrm>
+            <a:off x="5347106" y="2926080"/>
+            <a:ext cx="640080" cy="310896"/>
+          </a:xfrm>
+          <a:prstGeom prst="roundRect">
+            <a:avLst>
+              <a:gd name="adj" fmla="val 23529"/>
+            </a:avLst>
+          </a:prstGeom>
+          <a:solidFill>
+            <a:schemeClr val="accent3"/>
+          </a:solidFill>
+          <a:ln w="12700">
+            <a:solidFill>
+              <a:schemeClr val="accent3"/>
+            </a:solidFill>
+            <a:prstDash val="solid"/>
+          </a:ln>
+        </p:spPr>
+      </p:sp>
+      <p:sp>
+        <p:nvSpPr>
+          <p:cNvPr id="22" name="Text 18"/>
+          <p:cNvSpPr txBox="1"/>
+          <p:nvPr/>
+        </p:nvSpPr>
+        <p:spPr>
+          <a:xfrm>
+            <a:off x="5347106" y="2926080"/>
+            <a:ext cx="640080" cy="310896"/>
+          </a:xfrm>
+          <a:prstGeom prst="rect">
+            <a:avLst/>
+          </a:prstGeom>
+          <a:noFill/>
+          <a:ln/>
+        </p:spPr>
+        <p:txBody>
+          <a:bodyPr wrap="square" lIns="0" tIns="0" rIns="0" bIns="0" rtlCol="0" anchor="ctr"/>
+          <a:lstStyle/>
+          <a:p>
+            <a:pPr algn="ctr" indent="0" marL="0">
+              <a:buNone/>
+            </a:pPr>
+            <a:r>
+              <a:rPr lang="en-US" sz="1200" b="1" dirty="0">
+                <a:solidFill>
+                  <a:schemeClr val="bg1"/>
+                </a:solidFill>
+              </a:rPr>
+              <a:t>RQ3</a:t>
+            </a:r>
+            <a:endParaRPr lang="en-US" sz="1200" dirty="0"/>
+          </a:p>
+        </p:txBody>
+      </p:sp>
+      <p:sp>
+        <p:nvSpPr>
+          <p:cNvPr id="23" name="Text 19"/>
           <p:cNvSpPr txBox="1"/>
           <p:nvPr/>
         </p:nvSpPr>
@@ -9228,7 +9291,7 @@
                   <a:schemeClr val="tx1"/>
                 </a:solidFill>
               </a:rPr>
-              <a:t>SWOT heights from Hydrocron, checked against gauges</a:t>
+              <a:t>SWOT heights, checked against gauges</a:t>
             </a:r>
             <a:endParaRPr lang="en-US" sz="1400" dirty="0"/>
           </a:p>
@@ -9246,7 +9309,7 @@
                   <a:schemeClr val="tx1"/>
                 </a:solidFill>
               </a:rPr>
-              <a:t>Gauge data: daily records and history</a:t>
+              <a:t>A trust screen that cleans every reading</a:t>
             </a:r>
             <a:endParaRPr lang="en-US" sz="1400" dirty="0"/>
           </a:p>
@@ -9264,7 +9327,7 @@
                   <a:schemeClr val="tx1"/>
                 </a:solidFill>
               </a:rPr>
-              <a:t>Model: a SWOT trust model (gradient boosting)</a:t>
+              <a:t>Model: % full from height and area (gradient boosting)</a:t>
             </a:r>
             <a:endParaRPr lang="en-US" sz="1400" dirty="0"/>
           </a:p>
@@ -9272,7 +9335,7 @@
       </p:sp>
       <p:sp>
         <p:nvSpPr>
-          <p:cNvPr id="22" name="divider"/>
+          <p:cNvPr id="24" name="divider"/>
           <p:cNvSpPr/>
           <p:nvPr/>
         </p:nvSpPr>
@@ -9295,7 +9358,7 @@
       </p:sp>
       <p:sp>
         <p:nvSpPr>
-          <p:cNvPr id="23" name="Text 19"/>
+          <p:cNvPr id="25" name="Text 21"/>
           <p:cNvSpPr txBox="1"/>
           <p:nvPr/>
         </p:nvSpPr>
@@ -9334,7 +9397,7 @@
                   <a:schemeClr val="tx1"/>
                 </a:solidFill>
               </a:rPr>
-              <a:t>accuracy report and trust model</a:t>
+              <a:t>how full every tank is</a:t>
             </a:r>
             <a:endParaRPr lang="en-US" sz="1250" dirty="0"/>
           </a:p>
@@ -9342,7 +9405,7 @@
       </p:sp>
       <p:sp>
         <p:nvSpPr>
-          <p:cNvPr id="24" name="MEMBER C"/>
+          <p:cNvPr id="26" name="MEMBER C"/>
           <p:cNvSpPr/>
           <p:nvPr/>
         </p:nvSpPr>
@@ -9376,7 +9439,7 @@
       </p:sp>
       <p:sp>
         <p:nvSpPr>
-          <p:cNvPr id="25" name="icon FaChartLine"/>
+          <p:cNvPr id="27" name="icon FaChartLine"/>
           <p:cNvSpPr/>
           <p:nvPr/>
         </p:nvSpPr>
@@ -9401,7 +9464,7 @@
       </p:sp>
       <p:pic>
         <p:nvPicPr>
-          <p:cNvPr id="26" name="Image 2" descr="preencoded.png">    </p:cNvPr>
+          <p:cNvPr id="28" name="Image 2" descr="preencoded.png">    </p:cNvPr>
           <p:cNvPicPr>
             <a:picLocks noChangeAspect="1"/>
           </p:cNvPicPr>
@@ -9425,7 +9488,7 @@
       </p:pic>
       <p:sp>
         <p:nvSpPr>
-          <p:cNvPr id="27" name="Text 22"/>
+          <p:cNvPr id="29" name="Text 24"/>
           <p:cNvSpPr txBox="1"/>
           <p:nvPr/>
         </p:nvSpPr>
@@ -9461,7 +9524,7 @@
       </p:sp>
       <p:sp>
         <p:nvSpPr>
-          <p:cNvPr id="28" name="Text 23"/>
+          <p:cNvPr id="30" name="Text 25"/>
           <p:cNvSpPr txBox="1"/>
           <p:nvPr/>
         </p:nvSpPr>
@@ -9492,7 +9555,7 @@
                 <a:ea typeface="+mj-lt" pitchFamily="34" charset="-122"/>
                 <a:cs typeface="+mj-lt" pitchFamily="34" charset="-120"/>
               </a:rPr>
-              <a:t>Storage and forecast</a:t>
+              <a:t>Forecast and system</a:t>
             </a:r>
             <a:endParaRPr lang="en-US" sz="1900" dirty="0"/>
           </a:p>
@@ -9500,7 +9563,7 @@
       </p:sp>
       <p:sp>
         <p:nvSpPr>
-          <p:cNvPr id="29" name="RQ3"/>
+          <p:cNvPr id="31" name="RQ4"/>
           <p:cNvSpPr/>
           <p:nvPr/>
         </p:nvSpPr>
@@ -9527,76 +9590,13 @@
       </p:sp>
       <p:sp>
         <p:nvSpPr>
-          <p:cNvPr id="30" name="Text 25"/>
+          <p:cNvPr id="32" name="Text 27"/>
           <p:cNvSpPr txBox="1"/>
           <p:nvPr/>
         </p:nvSpPr>
         <p:spPr>
           <a:xfrm>
             <a:off x="8371637" y="2926080"/>
-            <a:ext cx="640080" cy="310896"/>
-          </a:xfrm>
-          <a:prstGeom prst="rect">
-            <a:avLst/>
-          </a:prstGeom>
-          <a:noFill/>
-          <a:ln/>
-        </p:spPr>
-        <p:txBody>
-          <a:bodyPr wrap="square" lIns="0" tIns="0" rIns="0" bIns="0" rtlCol="0" anchor="ctr"/>
-          <a:lstStyle/>
-          <a:p>
-            <a:pPr algn="ctr" indent="0" marL="0">
-              <a:buNone/>
-            </a:pPr>
-            <a:r>
-              <a:rPr lang="en-US" sz="1200" b="1" dirty="0">
-                <a:solidFill>
-                  <a:schemeClr val="bg1"/>
-                </a:solidFill>
-              </a:rPr>
-              <a:t>RQ3</a:t>
-            </a:r>
-            <a:endParaRPr lang="en-US" sz="1200" dirty="0"/>
-          </a:p>
-        </p:txBody>
-      </p:sp>
-      <p:sp>
-        <p:nvSpPr>
-          <p:cNvPr id="31" name="RQ4"/>
-          <p:cNvSpPr/>
-          <p:nvPr/>
-        </p:nvSpPr>
-        <p:spPr>
-          <a:xfrm>
-            <a:off x="9121445" y="2926080"/>
-            <a:ext cx="640080" cy="310896"/>
-          </a:xfrm>
-          <a:prstGeom prst="roundRect">
-            <a:avLst>
-              <a:gd name="adj" fmla="val 23529"/>
-            </a:avLst>
-          </a:prstGeom>
-          <a:solidFill>
-            <a:schemeClr val="accent2"/>
-          </a:solidFill>
-          <a:ln w="12700">
-            <a:solidFill>
-              <a:schemeClr val="accent2"/>
-            </a:solidFill>
-            <a:prstDash val="solid"/>
-          </a:ln>
-        </p:spPr>
-      </p:sp>
-      <p:sp>
-        <p:nvSpPr>
-          <p:cNvPr id="32" name="Text 27"/>
-          <p:cNvSpPr txBox="1"/>
-          <p:nvPr/>
-        </p:nvSpPr>
-        <p:spPr>
-          <a:xfrm>
-            <a:off x="9121445" y="2926080"/>
             <a:ext cx="640080" cy="310896"/>
           </a:xfrm>
           <a:prstGeom prst="rect">
@@ -9658,7 +9658,7 @@
                   <a:schemeClr val="tx1"/>
                 </a:solidFill>
               </a:rPr>
-              <a:t>Height–area–volume curve for each tank</a:t>
+              <a:t>Daily storage of 117 reservoirs, rain and evaporation</a:t>
             </a:r>
             <a:endParaRPr lang="en-US" sz="1400" dirty="0"/>
           </a:p>
@@ -9676,7 +9676,7 @@
                   <a:schemeClr val="tx1"/>
                 </a:solidFill>
               </a:rPr>
-              <a:t>Storage every 5–12 days, checked against official figures</a:t>
+              <a:t>The chain from picture to forecast, after every pass</a:t>
             </a:r>
             <a:endParaRPr lang="en-US" sz="1400" dirty="0"/>
           </a:p>
@@ -9764,7 +9764,7 @@
                   <a:schemeClr val="tx1"/>
                 </a:solidFill>
               </a:rPr>
-              <a:t>storage, forecast and dashboard</a:t>
+              <a:t>the forecast and the dashboard</a:t>
             </a:r>
             <a:endParaRPr lang="en-US" sz="1250" dirty="0"/>
           </a:p>
@@ -10732,7 +10732,7 @@
                   <a:schemeClr val="tx1"/>
                 </a:solidFill>
               </a:rPr>
-              <a:t>Member B: SWOT and gauges</a:t>
+              <a:t>Member B: SWOT and storage</a:t>
             </a:r>
             <a:endParaRPr lang="en-US" sz="3400" dirty="0"/>
           </a:p>
@@ -10803,14 +10803,41 @@
       </p:sp>
       <p:sp>
         <p:nvSpPr>
-          <p:cNvPr id="5" name="Text 3"/>
-          <p:cNvSpPr txBox="1"/>
-          <p:nvPr/>
-        </p:nvSpPr>
-        <p:spPr>
-          <a:xfrm>
-            <a:off x="1389888" y="1161288"/>
-            <a:ext cx="10253167" cy="411480"/>
+          <p:cNvPr id="5" name="RQ3"/>
+          <p:cNvSpPr/>
+          <p:nvPr/>
+        </p:nvSpPr>
+        <p:spPr>
+          <a:xfrm>
+            <a:off x="1298448" y="1207008"/>
+            <a:ext cx="640080" cy="310896"/>
+          </a:xfrm>
+          <a:prstGeom prst="roundRect">
+            <a:avLst>
+              <a:gd name="adj" fmla="val 23529"/>
+            </a:avLst>
+          </a:prstGeom>
+          <a:solidFill>
+            <a:schemeClr val="accent3"/>
+          </a:solidFill>
+          <a:ln w="12700">
+            <a:solidFill>
+              <a:schemeClr val="accent3"/>
+            </a:solidFill>
+            <a:prstDash val="solid"/>
+          </a:ln>
+        </p:spPr>
+      </p:sp>
+      <p:sp>
+        <p:nvSpPr>
+          <p:cNvPr id="6" name="Text 4"/>
+          <p:cNvSpPr txBox="1"/>
+          <p:nvPr/>
+        </p:nvSpPr>
+        <p:spPr>
+          <a:xfrm>
+            <a:off x="1298448" y="1207008"/>
+            <a:ext cx="640080" cy="310896"/>
           </a:xfrm>
           <a:prstGeom prst="rect">
             <a:avLst/>
@@ -10822,6 +10849,42 @@
           <a:bodyPr wrap="square" lIns="0" tIns="0" rIns="0" bIns="0" rtlCol="0" anchor="ctr"/>
           <a:lstStyle/>
           <a:p>
+            <a:pPr algn="ctr" indent="0" marL="0">
+              <a:buNone/>
+            </a:pPr>
+            <a:r>
+              <a:rPr lang="en-US" sz="1200" b="1" dirty="0">
+                <a:solidFill>
+                  <a:schemeClr val="bg1"/>
+                </a:solidFill>
+              </a:rPr>
+              <a:t>RQ3</a:t>
+            </a:r>
+            <a:endParaRPr lang="en-US" sz="1200" dirty="0"/>
+          </a:p>
+        </p:txBody>
+      </p:sp>
+      <p:sp>
+        <p:nvSpPr>
+          <p:cNvPr id="7" name="Text 5"/>
+          <p:cNvSpPr txBox="1"/>
+          <p:nvPr/>
+        </p:nvSpPr>
+        <p:spPr>
+          <a:xfrm>
+            <a:off x="2139696" y="1161288"/>
+            <a:ext cx="9503359" cy="411480"/>
+          </a:xfrm>
+          <a:prstGeom prst="rect">
+            <a:avLst/>
+          </a:prstGeom>
+          <a:noFill/>
+          <a:ln/>
+        </p:spPr>
+        <p:txBody>
+          <a:bodyPr wrap="square" lIns="0" tIns="0" rIns="0" bIns="0" rtlCol="0" anchor="ctr"/>
+          <a:lstStyle/>
+          <a:p>
             <a:pPr indent="0" marL="0">
               <a:buNone/>
             </a:pPr>
@@ -10831,7 +10894,7 @@
                   <a:schemeClr val="accent6"/>
                 </a:solidFill>
               </a:rPr>
-              <a:t>How accurate is SWOT on reservoirs and village tanks, and can a learned model tell which readings to trust better than SWOT's own flags?</a:t>
+              <a:t>How accurate is SWOT, and can a model trained on about 100 reservoirs turn SWOT height and water area into % full for new tanks?</a:t>
             </a:r>
             <a:endParaRPr lang="en-US" sz="1400" dirty="0"/>
           </a:p>
@@ -10839,7 +10902,7 @@
       </p:sp>
       <p:sp>
         <p:nvSpPr>
-          <p:cNvPr id="6" name="Data analysis"/>
+          <p:cNvPr id="8" name="Data analysis"/>
           <p:cNvSpPr/>
           <p:nvPr/>
         </p:nvSpPr>
@@ -10866,7 +10929,7 @@
       </p:sp>
       <p:sp>
         <p:nvSpPr>
-          <p:cNvPr id="7" name="icon FaChartColumn"/>
+          <p:cNvPr id="9" name="icon FaChartColumn"/>
           <p:cNvSpPr/>
           <p:nvPr/>
         </p:nvSpPr>
@@ -10891,7 +10954,7 @@
       </p:sp>
       <p:pic>
         <p:nvPicPr>
-          <p:cNvPr id="8" name="Image 0" descr="preencoded.png">    </p:cNvPr>
+          <p:cNvPr id="10" name="Image 0" descr="preencoded.png">    </p:cNvPr>
           <p:cNvPicPr>
             <a:picLocks noChangeAspect="1"/>
           </p:cNvPicPr>
@@ -10915,7 +10978,7 @@
       </p:pic>
       <p:sp>
         <p:nvSpPr>
-          <p:cNvPr id="9" name="Text 6"/>
+          <p:cNvPr id="11" name="Text 8"/>
           <p:cNvSpPr txBox="1"/>
           <p:nvPr/>
         </p:nvSpPr>
@@ -10954,7 +11017,7 @@
       </p:sp>
       <p:sp>
         <p:nvSpPr>
-          <p:cNvPr id="10" name="Text 7"/>
+          <p:cNvPr id="12" name="Text 9"/>
           <p:cNvSpPr txBox="1"/>
           <p:nvPr/>
         </p:nvSpPr>
@@ -10986,7 +11049,7 @@
                   <a:schemeClr val="tx1"/>
                 </a:solidFill>
               </a:rPr>
-              <a:t>SWOT minus gauge on every pass: the average gap and the spread in cm</a:t>
+              <a:t>SWOT minus gauge on every pass: the steady gap and the spread in cm</a:t>
             </a:r>
             <a:endParaRPr lang="en-US" sz="1500" dirty="0"/>
           </a:p>
@@ -11004,7 +11067,7 @@
                   <a:schemeClr val="tx1"/>
                 </a:solidFill>
               </a:rPr>
-              <a:t>Labels for the model: each reading's error at the 117 department reservoirs</a:t>
+              <a:t>Trust screen: how many "suspect" readings it keeps, and their error</a:t>
             </a:r>
             <a:endParaRPr lang="en-US" sz="1500" dirty="0"/>
           </a:p>
@@ -11022,7 +11085,7 @@
                   <a:schemeClr val="tx1"/>
                 </a:solidFill>
               </a:rPr>
-              <a:t>The trust model against SWOT's own flags, on reservoirs it never saw</a:t>
+              <a:t>Training pairs: daily storage with SWOT height and water area, at about 100 reservoirs</a:t>
             </a:r>
             <a:endParaRPr lang="en-US" sz="1500" dirty="0"/>
           </a:p>
@@ -11040,7 +11103,7 @@
                   <a:schemeClr val="tx1"/>
                 </a:solidFill>
               </a:rPr>
-              <a:t>How a height error turns into a volume error</a:t>
+              <a:t>Storage error in % of capacity on reservoirs the model never saw, against one formula and Imbulana's equation</a:t>
             </a:r>
             <a:endParaRPr lang="en-US" sz="1500" dirty="0"/>
           </a:p>
@@ -11048,7 +11111,7 @@
       </p:sp>
       <p:sp>
         <p:nvSpPr>
-          <p:cNvPr id="11" name="Technical work"/>
+          <p:cNvPr id="13" name="Technical work"/>
           <p:cNvSpPr/>
           <p:nvPr/>
         </p:nvSpPr>
@@ -11082,7 +11145,7 @@
       </p:sp>
       <p:sp>
         <p:nvSpPr>
-          <p:cNvPr id="12" name="icon FaGears"/>
+          <p:cNvPr id="14" name="icon FaGears"/>
           <p:cNvSpPr/>
           <p:nvPr/>
         </p:nvSpPr>
@@ -11107,7 +11170,7 @@
       </p:sp>
       <p:pic>
         <p:nvPicPr>
-          <p:cNvPr id="13" name="Image 1" descr="preencoded.png">    </p:cNvPr>
+          <p:cNvPr id="15" name="Image 1" descr="preencoded.png">    </p:cNvPr>
           <p:cNvPicPr>
             <a:picLocks noChangeAspect="1"/>
           </p:cNvPicPr>
@@ -11131,7 +11194,7 @@
       </p:pic>
       <p:sp>
         <p:nvSpPr>
-          <p:cNvPr id="14" name="Text 10"/>
+          <p:cNvPr id="16" name="Text 12"/>
           <p:cNvSpPr txBox="1"/>
           <p:nvPr/>
         </p:nvSpPr>
@@ -11170,7 +11233,7 @@
       </p:sp>
       <p:sp>
         <p:nvSpPr>
-          <p:cNvPr id="15" name="Text 11"/>
+          <p:cNvPr id="17" name="Text 13"/>
           <p:cNvSpPr txBox="1"/>
           <p:nvPr/>
         </p:nvSpPr>
@@ -11220,7 +11283,7 @@
                   <a:schemeClr val="tx1"/>
                 </a:solidFill>
               </a:rPr>
-              <a:t>Trust model: gradient boosting (XGBoost or LightGBM) on SWOT's quality fields, track distance, lake size and season</a:t>
+              <a:t>Trust screen: gradient boosting on SWOT's quality fields, track distance, lake size and season</a:t>
             </a:r>
             <a:endParaRPr lang="en-US" sz="1500" dirty="0"/>
           </a:p>
@@ -11238,7 +11301,7 @@
                   <a:schemeClr val="tx1"/>
                 </a:solidFill>
               </a:rPr>
-              <a:t>Gauge zero in metres above sea level: full supply level minus full supply depth</a:t>
+              <a:t>Storage model: gradient boosting in which more height or area never means less water</a:t>
             </a:r>
             <a:endParaRPr lang="en-US" sz="1500" dirty="0"/>
           </a:p>
@@ -11256,7 +11319,7 @@
                   <a:schemeClr val="tx1"/>
                 </a:solidFill>
               </a:rPr>
-              <a:t>Daily logger for the department's sheet; storage history turned back into gauge heights</a:t>
+              <a:t>Inputs every tank has: height, area, outline, catchment and slope (Copernicus DEM)</a:t>
             </a:r>
             <a:endParaRPr lang="en-US" sz="1500" dirty="0"/>
           </a:p>
@@ -11264,7 +11327,7 @@
       </p:sp>
       <p:sp>
         <p:nvSpPr>
-          <p:cNvPr id="16" name="output"/>
+          <p:cNvPr id="18" name="output"/>
           <p:cNvSpPr/>
           <p:nvPr/>
         </p:nvSpPr>
@@ -11291,7 +11354,7 @@
       </p:sp>
       <p:sp>
         <p:nvSpPr>
-          <p:cNvPr id="17" name="icon FaFlagCheckered"/>
+          <p:cNvPr id="19" name="icon FaFlagCheckered"/>
           <p:cNvSpPr/>
           <p:nvPr/>
         </p:nvSpPr>
@@ -11316,7 +11379,7 @@
       </p:sp>
       <p:pic>
         <p:nvPicPr>
-          <p:cNvPr id="18" name="Image 2" descr="preencoded.png">    </p:cNvPr>
+          <p:cNvPr id="20" name="Image 2" descr="preencoded.png">    </p:cNvPr>
           <p:cNvPicPr>
             <a:picLocks noChangeAspect="1"/>
           </p:cNvPicPr>
@@ -11340,7 +11403,7 @@
       </p:pic>
       <p:sp>
         <p:nvSpPr>
-          <p:cNvPr id="19" name="Text 14"/>
+          <p:cNvPr id="21" name="Text 16"/>
           <p:cNvSpPr txBox="1"/>
           <p:nvPr/>
         </p:nvSpPr>
@@ -11379,7 +11442,7 @@
                   <a:schemeClr val="bg1"/>
                 </a:solidFill>
               </a:rPr>
-              <a:t>SWOT accuracy report, the fixed gap for each reservoir, and a trust model that scores every reading</a:t>
+              <a:t>SWOT accuracy report, a screen that cleans every reading, and a model that says how full any tank is</a:t>
             </a:r>
             <a:endParaRPr lang="en-US" sz="1500" dirty="0"/>
           </a:p>
@@ -11487,7 +11550,7 @@
                   <a:schemeClr val="tx1"/>
                 </a:solidFill>
               </a:rPr>
-              <a:t>Member C: Storage and forecast</a:t>
+              <a:t>Member C: Forecast and system</a:t>
             </a:r>
             <a:endParaRPr lang="en-US" sz="3400" dirty="0"/>
           </a:p>
@@ -11495,7 +11558,7 @@
       </p:sp>
       <p:sp>
         <p:nvSpPr>
-          <p:cNvPr id="3" name="RQ3"/>
+          <p:cNvPr id="3" name="RQ4"/>
           <p:cNvSpPr/>
           <p:nvPr/>
         </p:nvSpPr>
@@ -11550,7 +11613,7 @@
                   <a:schemeClr val="bg1"/>
                 </a:solidFill>
               </a:rPr>
-              <a:t>RQ3</a:t>
+              <a:t>RQ4</a:t>
             </a:r>
             <a:endParaRPr lang="en-US" sz="1200" dirty="0"/>
           </a:p>
@@ -11558,19 +11621,80 @@
       </p:sp>
       <p:sp>
         <p:nvSpPr>
-          <p:cNvPr id="5" name="RQ4"/>
+          <p:cNvPr id="5" name="Text 3"/>
+          <p:cNvSpPr txBox="1"/>
+          <p:nvPr/>
+        </p:nvSpPr>
+        <p:spPr>
+          <a:xfrm>
+            <a:off x="1389888" y="1161288"/>
+            <a:ext cx="10253167" cy="411480"/>
+          </a:xfrm>
+          <a:prstGeom prst="rect">
+            <a:avLst/>
+          </a:prstGeom>
+          <a:noFill/>
+          <a:ln/>
+        </p:spPr>
+        <p:txBody>
+          <a:bodyPr wrap="square" lIns="0" tIns="0" rIns="0" bIns="0" rtlCol="0" anchor="ctr"/>
+          <a:lstStyle/>
+          <a:p>
+            <a:pPr indent="0" marL="0">
+              <a:buNone/>
+            </a:pPr>
+            <a:r>
+              <a:rPr lang="en-US" sz="1400" dirty="0">
+                <a:solidFill>
+                  <a:schemeClr val="accent6"/>
+                </a:solidFill>
+              </a:rPr>
+              <a:t>Can a deep-learning model forecast each tank's storage 2–4 weeks ahead, from recent storage, rain and evaporation, better than "no change"?</a:t>
+            </a:r>
+            <a:endParaRPr lang="en-US" sz="1400" dirty="0"/>
+          </a:p>
+        </p:txBody>
+      </p:sp>
+      <p:sp>
+        <p:nvSpPr>
+          <p:cNvPr id="6" name="Data analysis"/>
           <p:cNvSpPr/>
           <p:nvPr/>
         </p:nvSpPr>
         <p:spPr>
           <a:xfrm>
-            <a:off x="1298448" y="1207008"/>
-            <a:ext cx="640080" cy="310896"/>
+            <a:off x="548640" y="1783080"/>
+            <a:ext cx="5410048" cy="3611880"/>
           </a:xfrm>
           <a:prstGeom prst="roundRect">
             <a:avLst>
-              <a:gd name="adj" fmla="val 23529"/>
+              <a:gd name="adj" fmla="val 3038"/>
             </a:avLst>
+          </a:prstGeom>
+          <a:solidFill>
+            <a:schemeClr val="bg2"/>
+          </a:solidFill>
+          <a:ln w="9525">
+            <a:solidFill>
+              <a:schemeClr val="bg2"/>
+            </a:solidFill>
+            <a:prstDash val="solid"/>
+          </a:ln>
+        </p:spPr>
+      </p:sp>
+      <p:sp>
+        <p:nvSpPr>
+          <p:cNvPr id="7" name="icon FaChartColumn"/>
+          <p:cNvSpPr/>
+          <p:nvPr/>
+        </p:nvSpPr>
+        <p:spPr>
+          <a:xfrm>
+            <a:off x="822960" y="1947672"/>
+            <a:ext cx="457200" cy="457200"/>
+          </a:xfrm>
+          <a:prstGeom prst="ellipse">
+            <a:avLst/>
           </a:prstGeom>
           <a:solidFill>
             <a:schemeClr val="accent2"/>
@@ -11583,133 +11707,9 @@
           </a:ln>
         </p:spPr>
       </p:sp>
-      <p:sp>
-        <p:nvSpPr>
-          <p:cNvPr id="6" name="Text 4"/>
-          <p:cNvSpPr txBox="1"/>
-          <p:nvPr/>
-        </p:nvSpPr>
-        <p:spPr>
-          <a:xfrm>
-            <a:off x="1298448" y="1207008"/>
-            <a:ext cx="640080" cy="310896"/>
-          </a:xfrm>
-          <a:prstGeom prst="rect">
-            <a:avLst/>
-          </a:prstGeom>
-          <a:noFill/>
-          <a:ln/>
-        </p:spPr>
-        <p:txBody>
-          <a:bodyPr wrap="square" lIns="0" tIns="0" rIns="0" bIns="0" rtlCol="0" anchor="ctr"/>
-          <a:lstStyle/>
-          <a:p>
-            <a:pPr algn="ctr" indent="0" marL="0">
-              <a:buNone/>
-            </a:pPr>
-            <a:r>
-              <a:rPr lang="en-US" sz="1200" b="1" dirty="0">
-                <a:solidFill>
-                  <a:schemeClr val="bg1"/>
-                </a:solidFill>
-              </a:rPr>
-              <a:t>RQ4</a:t>
-            </a:r>
-            <a:endParaRPr lang="en-US" sz="1200" dirty="0"/>
-          </a:p>
-        </p:txBody>
-      </p:sp>
-      <p:sp>
-        <p:nvSpPr>
-          <p:cNvPr id="7" name="Text 5"/>
-          <p:cNvSpPr txBox="1"/>
-          <p:nvPr/>
-        </p:nvSpPr>
-        <p:spPr>
-          <a:xfrm>
-            <a:off x="2139696" y="1161288"/>
-            <a:ext cx="9503359" cy="411480"/>
-          </a:xfrm>
-          <a:prstGeom prst="rect">
-            <a:avLst/>
-          </a:prstGeom>
-          <a:noFill/>
-          <a:ln/>
-        </p:spPr>
-        <p:txBody>
-          <a:bodyPr wrap="square" lIns="0" tIns="0" rIns="0" bIns="0" rtlCol="0" anchor="ctr"/>
-          <a:lstStyle/>
-          <a:p>
-            <a:pPr indent="0" marL="0">
-              <a:buNone/>
-            </a:pPr>
-            <a:r>
-              <a:rPr lang="en-US" sz="1400" dirty="0">
-                <a:solidFill>
-                  <a:schemeClr val="accent6"/>
-                </a:solidFill>
-              </a:rPr>
-              <a:t>Does AI water area plus SWOT height give storage close to official values, and can a deep-learning model forecast it 2–4 weeks ahead?</a:t>
-            </a:r>
-            <a:endParaRPr lang="en-US" sz="1400" dirty="0"/>
-          </a:p>
-        </p:txBody>
-      </p:sp>
-      <p:sp>
-        <p:nvSpPr>
-          <p:cNvPr id="8" name="Data analysis"/>
-          <p:cNvSpPr/>
-          <p:nvPr/>
-        </p:nvSpPr>
-        <p:spPr>
-          <a:xfrm>
-            <a:off x="548640" y="1783080"/>
-            <a:ext cx="5410048" cy="3611880"/>
-          </a:xfrm>
-          <a:prstGeom prst="roundRect">
-            <a:avLst>
-              <a:gd name="adj" fmla="val 3038"/>
-            </a:avLst>
-          </a:prstGeom>
-          <a:solidFill>
-            <a:schemeClr val="bg2"/>
-          </a:solidFill>
-          <a:ln w="9525">
-            <a:solidFill>
-              <a:schemeClr val="bg2"/>
-            </a:solidFill>
-            <a:prstDash val="solid"/>
-          </a:ln>
-        </p:spPr>
-      </p:sp>
-      <p:sp>
-        <p:nvSpPr>
-          <p:cNvPr id="9" name="icon FaChartColumn"/>
-          <p:cNvSpPr/>
-          <p:nvPr/>
-        </p:nvSpPr>
-        <p:spPr>
-          <a:xfrm>
-            <a:off x="822960" y="1947672"/>
-            <a:ext cx="457200" cy="457200"/>
-          </a:xfrm>
-          <a:prstGeom prst="ellipse">
-            <a:avLst/>
-          </a:prstGeom>
-          <a:solidFill>
-            <a:schemeClr val="accent2"/>
-          </a:solidFill>
-          <a:ln w="12700">
-            <a:solidFill>
-              <a:schemeClr val="accent2"/>
-            </a:solidFill>
-            <a:prstDash val="solid"/>
-          </a:ln>
-        </p:spPr>
-      </p:sp>
       <p:pic>
         <p:nvPicPr>
-          <p:cNvPr id="10" name="Image 0" descr="preencoded.png">    </p:cNvPr>
+          <p:cNvPr id="8" name="Image 0" descr="preencoded.png">    </p:cNvPr>
           <p:cNvPicPr>
             <a:picLocks noChangeAspect="1"/>
           </p:cNvPicPr>
@@ -11733,7 +11733,7 @@
       </p:pic>
       <p:sp>
         <p:nvSpPr>
-          <p:cNvPr id="11" name="Text 8"/>
+          <p:cNvPr id="9" name="Text 6"/>
           <p:cNvSpPr txBox="1"/>
           <p:nvPr/>
         </p:nvSpPr>
@@ -11772,7 +11772,7 @@
       </p:sp>
       <p:sp>
         <p:nvSpPr>
-          <p:cNvPr id="12" name="Text 9"/>
+          <p:cNvPr id="10" name="Text 7"/>
           <p:cNvSpPr txBox="1"/>
           <p:nvPr/>
         </p:nvSpPr>
@@ -11804,7 +11804,7 @@
                   <a:schemeClr val="tx1"/>
                 </a:solidFill>
               </a:rPr>
-              <a:t>Each tank's area–height curve A(h) from its dots</a:t>
+              <a:t>Seasonal average for each tank, from past years only</a:t>
             </a:r>
             <a:endParaRPr lang="en-US" sz="1500" dirty="0"/>
           </a:p>
@@ -11822,7 +11822,7 @@
                   <a:schemeClr val="tx1"/>
                 </a:solidFill>
               </a:rPr>
-              <a:t>Storage change against the department's daily storage</a:t>
+              <a:t>Forecast error at 1, 2 and 4 weeks, against "no change" and the seasonal average</a:t>
             </a:r>
             <a:endParaRPr lang="en-US" sz="1500" dirty="0"/>
           </a:p>
@@ -11840,7 +11840,7 @@
                   <a:schemeClr val="tx1"/>
                 </a:solidFill>
               </a:rPr>
-              <a:t>Test the method on Kanhindawewa's drone table, and against Imbulana's formula</a:t>
+              <a:t>Tested on years and reservoirs the model never saw</a:t>
             </a:r>
             <a:endParaRPr lang="en-US" sz="1500" dirty="0"/>
           </a:p>
@@ -11858,7 +11858,7 @@
                   <a:schemeClr val="tx1"/>
                 </a:solidFill>
               </a:rPr>
-              <a:t>Forecast error at 1, 2 and 4 weeks, against "no change" and the seasonal average</a:t>
+              <a:t>The whole chain, picture to forecast, at the village tanks and on Kanhindawewa's drone survey</a:t>
             </a:r>
             <a:endParaRPr lang="en-US" sz="1500" dirty="0"/>
           </a:p>
@@ -11866,7 +11866,7 @@
       </p:sp>
       <p:sp>
         <p:nvSpPr>
-          <p:cNvPr id="13" name="Technical work"/>
+          <p:cNvPr id="11" name="Technical work"/>
           <p:cNvSpPr/>
           <p:nvPr/>
         </p:nvSpPr>
@@ -11900,7 +11900,7 @@
       </p:sp>
       <p:sp>
         <p:nvSpPr>
-          <p:cNvPr id="14" name="icon FaGears"/>
+          <p:cNvPr id="12" name="icon FaGears"/>
           <p:cNvSpPr/>
           <p:nvPr/>
         </p:nvSpPr>
@@ -11925,7 +11925,7 @@
       </p:sp>
       <p:pic>
         <p:nvPicPr>
-          <p:cNvPr id="15" name="Image 1" descr="preencoded.png">    </p:cNvPr>
+          <p:cNvPr id="13" name="Image 1" descr="preencoded.png">    </p:cNvPr>
           <p:cNvPicPr>
             <a:picLocks noChangeAspect="1"/>
           </p:cNvPicPr>
@@ -11949,7 +11949,7 @@
       </p:pic>
       <p:sp>
         <p:nvSpPr>
-          <p:cNvPr id="16" name="Text 12"/>
+          <p:cNvPr id="14" name="Text 10"/>
           <p:cNvSpPr txBox="1"/>
           <p:nvPr/>
         </p:nvSpPr>
@@ -11988,7 +11988,7 @@
       </p:sp>
       <p:sp>
         <p:nvSpPr>
-          <p:cNvPr id="17" name="Text 13"/>
+          <p:cNvPr id="15" name="Text 11"/>
           <p:cNvSpPr txBox="1"/>
           <p:nvPr/>
         </p:nvSpPr>
@@ -12020,7 +12020,7 @@
                   <a:schemeClr val="tx1"/>
                 </a:solidFill>
               </a:rPr>
-              <a:t>Storage engine: dots, curve, thin layers and safe limits, after every pass</a:t>
+              <a:t>Forecast model: an LSTM with a gradient-boosting baseline, trained on 117 reservoirs' daily storage (2020–2026), rain and evaporation</a:t>
             </a:r>
             <a:endParaRPr lang="en-US" sz="1500" dirty="0"/>
           </a:p>
@@ -12038,7 +12038,7 @@
                   <a:schemeClr val="tx1"/>
                 </a:solidFill>
               </a:rPr>
-              <a:t>Forecast model: an LSTM with a gradient-boosting baseline, trained on 117 reservoirs' daily storage (2020–2026), rain and evaporation</a:t>
+              <a:t>The chain after every pass: A's water map and SWOT's height go into B's model</a:t>
             </a:r>
             <a:endParaRPr lang="en-US" sz="1500" dirty="0"/>
           </a:p>
@@ -12082,7 +12082,7 @@
       </p:sp>
       <p:sp>
         <p:nvSpPr>
-          <p:cNvPr id="18" name="output"/>
+          <p:cNvPr id="16" name="output"/>
           <p:cNvSpPr/>
           <p:nvPr/>
         </p:nvSpPr>
@@ -12109,7 +12109,7 @@
       </p:sp>
       <p:sp>
         <p:nvSpPr>
-          <p:cNvPr id="19" name="icon FaFlagCheckered"/>
+          <p:cNvPr id="17" name="icon FaFlagCheckered"/>
           <p:cNvSpPr/>
           <p:nvPr/>
         </p:nvSpPr>
@@ -12134,7 +12134,7 @@
       </p:sp>
       <p:pic>
         <p:nvPicPr>
-          <p:cNvPr id="20" name="Image 2" descr="preencoded.png">    </p:cNvPr>
+          <p:cNvPr id="18" name="Image 2" descr="preencoded.png">    </p:cNvPr>
           <p:cNvPicPr>
             <a:picLocks noChangeAspect="1"/>
           </p:cNvPicPr>
@@ -12158,7 +12158,7 @@
       </p:pic>
       <p:sp>
         <p:nvSpPr>
-          <p:cNvPr id="21" name="Text 16"/>
+          <p:cNvPr id="19" name="Text 14"/>
           <p:cNvSpPr txBox="1"/>
           <p:nvPr/>
         </p:nvSpPr>
@@ -12197,7 +12197,7 @@
                   <a:schemeClr val="bg1"/>
                 </a:solidFill>
               </a:rPr>
-              <a:t>storage for every tank with safe limits, and a 2–4 week forecast, on a dashboard</a:t>
+              <a:t>a 2–4 week forecast for every tank, the running chain and the dashboard</a:t>
             </a:r>
             <a:endParaRPr lang="en-US" sz="1500" dirty="0"/>
           </a:p>
@@ -12475,7 +12475,7 @@
                   <a:schemeClr val="tx1"/>
                 </a:solidFill>
               </a:rPr>
-              <a:t>A SWOT trust model that scores every reading</a:t>
+              <a:t>A SWOT trust screen, and a model that turns height and area into % full</a:t>
             </a:r>
             <a:endParaRPr lang="en-US" sz="1600" dirty="0"/>
           </a:p>
@@ -12560,7 +12560,7 @@
                   <a:schemeClr val="tx1"/>
                 </a:solidFill>
               </a:rPr>
-              <a:t>Curves and storage every 5–12 days for all 13 tanks</a:t>
+              <a:t>Storage every 5–12 days for all 13 tanks</a:t>
             </a:r>
             <a:endParaRPr lang="en-US" sz="1600" dirty="0"/>
           </a:p>
@@ -13080,7 +13080,7 @@
                   <a:schemeClr val="accent6"/>
                 </a:solidFill>
               </a:rPr>
-              <a:t>Labelled data, gauge readings, and the three models: water map, trust model, forecast</a:t>
+              <a:t>Labelled data, gauge readings, and the three models: water map, storage model, forecast</a:t>
             </a:r>
             <a:endParaRPr lang="en-US" sz="1250" dirty="0"/>
           </a:p>

</xml_diff>

<commit_message>
Final proposal and slides (approved, 29 Oct 2026)
The final proposal PDF and its text: RQ3 against one area-storage formula, the cascade check, new baselines (the Brazil SWOT filter, NASA OPERA maps), IMERG for daily rain, fixed ICITR and Madumalsha links. The slides match it; the deck and its builder are without speaker notes.
</commit_message>
<xml_diff>
--- a/swot-tank-tracker/presentation/SWOT Tank Water Tracker - proposal talk.pptx
+++ b/swot-tank-tracker/presentation/SWOT Tank Water Tracker - proposal talk.pptx
@@ -127,7 +127,7 @@
   <p:extLst>
     <p:ext uri="{521415D9-36F7-43E2-AB2F-B90AF26B5E84}">
       <p14:sectionLst xmlns:p14="http://schemas.microsoft.com/office/powerpoint/2010/main">
-        <p14:section name="Introduction" id="{3f6419a0-d7b3-caf8-cefb-36542fd2a945}">
+        <p14:section name="Introduction" id="{f81e3bdb-39ac-99b7-357a-9393e33d6931}">
           <p14:sldIdLst>
             <p14:sldId id="256"/>
             <p14:sldId id="257"/>
@@ -135,28 +135,28 @@
             <p14:sldId id="259"/>
           </p14:sldIdLst>
         </p14:section>
-        <p14:section name="The satellites" id="{6341b1b3-8d9f-6374-326b-68f42ca05fc6}">
+        <p14:section name="The satellites" id="{db251148-a154-e12f-6825-9dda8b65ed1c}">
           <p14:sldIdLst>
             <p14:sldId id="260"/>
             <p14:sldId id="261"/>
             <p14:sldId id="262"/>
           </p14:sldIdLst>
         </p14:section>
-        <p14:section name="Study and method" id="{cec30c08-7fc8-29b7-d9d6-6d1ed1a64b5b}">
+        <p14:section name="Study and method" id="{50a27b4f-4321-fbca-c55d-b142010bbaeb}">
           <p14:sldIdLst>
             <p14:sldId id="263"/>
             <p14:sldId id="264"/>
             <p14:sldId id="265"/>
           </p14:sldIdLst>
         </p14:section>
-        <p14:section name="Evidence" id="{d575cb99-b694-f74a-3146-9f6fea1ed83d}">
+        <p14:section name="Evidence" id="{91b74a35-f3f0-bee9-cf86-363ee21ce51e}">
           <p14:sldIdLst>
             <p14:sldId id="266"/>
             <p14:sldId id="267"/>
             <p14:sldId id="268"/>
           </p14:sldIdLst>
         </p14:section>
-        <p14:section name="Plan" id="{370aa6a0-fe83-f063-c81c-f39cb5cfa854}">
+        <p14:section name="Plan" id="{b7a470ed-8f5c-e574-ea44-a704798c720d}">
           <p14:sldIdLst>
             <p14:sldId id="269"/>
             <p14:sldId id="270"/>
@@ -11103,7 +11103,7 @@
                   <a:schemeClr val="tx1"/>
                 </a:solidFill>
               </a:rPr>
-              <a:t>Storage error in % of capacity on reservoirs the model never saw, against one formula and Imbulana's equation</a:t>
+              <a:t>Storage error in % of capacity on reservoirs the model never saw, against one formula for all tanks</a:t>
             </a:r>
             <a:endParaRPr lang="en-US" sz="1500" dirty="0"/>
           </a:p>
@@ -12980,7 +12980,7 @@
                   <a:schemeClr val="accent6"/>
                 </a:solidFill>
               </a:rPr>
-              <a:t>Study area confirmed after the cascade and name checks</a:t>
+              <a:t>Study area confirmed after the name check</a:t>
             </a:r>
             <a:endParaRPr lang="en-US" sz="1250" dirty="0"/>
           </a:p>
@@ -13882,7 +13882,7 @@
                   <a:schemeClr val="bg1"/>
                 </a:solidFill>
               </a:rPr>
-              <a:t>432 tanks of 6.25 ha or more in our study area (blue)</a:t>
+              <a:t>432 tanks of 6.25 ha or more on this map (blue)</a:t>
             </a:r>
             <a:endParaRPr lang="en-US" sz="1500" dirty="0"/>
           </a:p>
@@ -14564,46 +14564,7 @@
         </p:nvSpPr>
         <p:spPr>
           <a:xfrm>
-            <a:off x="6278728" y="1691640"/>
-            <a:ext cx="5364328" cy="329184"/>
-          </a:xfrm>
-          <a:prstGeom prst="rect">
-            <a:avLst/>
-          </a:prstGeom>
-          <a:noFill/>
-          <a:ln/>
-        </p:spPr>
-        <p:txBody>
-          <a:bodyPr wrap="square" lIns="0" tIns="0" rIns="0" bIns="0" rtlCol="0" anchor="ctr"/>
-          <a:lstStyle/>
-          <a:p>
-            <a:pPr indent="0" marL="0">
-              <a:buNone/>
-            </a:pPr>
-            <a:r>
-              <a:rPr lang="en-US" sz="1500" dirty="0">
-                <a:solidFill>
-                  <a:schemeClr val="tx1"/>
-                </a:solidFill>
-                <a:latin typeface="+mj-lt" pitchFamily="34" charset="0"/>
-                <a:ea typeface="+mj-lt" pitchFamily="34" charset="-122"/>
-                <a:cs typeface="+mj-lt" pitchFamily="34" charset="-120"/>
-              </a:rPr>
-              <a:t>Ground truth</a:t>
-            </a:r>
-            <a:endParaRPr lang="en-US" sz="1500" dirty="0"/>
-          </a:p>
-        </p:txBody>
-      </p:sp>
-      <p:sp>
-        <p:nvSpPr>
-          <p:cNvPr id="15" name="Text 13"/>
-          <p:cNvSpPr txBox="1"/>
-          <p:nvPr/>
-        </p:nvSpPr>
-        <p:spPr>
-          <a:xfrm>
-            <a:off x="6415888" y="2075688"/>
+            <a:off x="685800" y="5093208"/>
             <a:ext cx="5227168" cy="292608"/>
           </a:xfrm>
           <a:prstGeom prst="rect">
@@ -14632,7 +14593,7 @@
                   </a:extLst>
                 </a:hlinkClick>
               </a:rPr>
-              <a:t>Irrigation Department: reservoir water level</a:t>
+              <a:t>Global Water Watch archive</a:t>
             </a:r>
             <a:pPr indent="0" marL="0">
               <a:buNone/>
@@ -14643,7 +14604,7 @@
                   <a:schemeClr val="accent6"/>
                 </a:solidFill>
               </a:rPr>
-              <a:t>  the daily sheet</a:t>
+              <a:t>  reservoir water areas</a:t>
             </a:r>
             <a:endParaRPr lang="en-US" sz="1250" dirty="0"/>
           </a:p>
@@ -14651,13 +14612,52 @@
       </p:sp>
       <p:sp>
         <p:nvSpPr>
+          <p:cNvPr id="15" name="Text 13"/>
+          <p:cNvSpPr txBox="1"/>
+          <p:nvPr/>
+        </p:nvSpPr>
+        <p:spPr>
+          <a:xfrm>
+            <a:off x="548640" y="5550408"/>
+            <a:ext cx="5364328" cy="329184"/>
+          </a:xfrm>
+          <a:prstGeom prst="rect">
+            <a:avLst/>
+          </a:prstGeom>
+          <a:noFill/>
+          <a:ln/>
+        </p:spPr>
+        <p:txBody>
+          <a:bodyPr wrap="square" lIns="0" tIns="0" rIns="0" bIns="0" rtlCol="0" anchor="ctr"/>
+          <a:lstStyle/>
+          <a:p>
+            <a:pPr indent="0" marL="0">
+              <a:buNone/>
+            </a:pPr>
+            <a:r>
+              <a:rPr lang="en-US" sz="1500" dirty="0">
+                <a:solidFill>
+                  <a:schemeClr val="tx1"/>
+                </a:solidFill>
+                <a:latin typeface="+mj-lt" pitchFamily="34" charset="0"/>
+                <a:ea typeface="+mj-lt" pitchFamily="34" charset="-122"/>
+                <a:cs typeface="+mj-lt" pitchFamily="34" charset="-120"/>
+              </a:rPr>
+              <a:t>Ground shape</a:t>
+            </a:r>
+            <a:endParaRPr lang="en-US" sz="1500" dirty="0"/>
+          </a:p>
+        </p:txBody>
+      </p:sp>
+      <p:sp>
+        <p:nvSpPr>
           <p:cNvPr id="16" name="Text 14"/>
           <p:cNvSpPr txBox="1"/>
           <p:nvPr/>
         </p:nvSpPr>
         <p:spPr>
           <a:xfrm>
-            <a:off x="6415888" y="2386584"/>
+            <a:off x="685800" y="5934456"/>
             <a:ext cx="5227168" cy="292608"/>
           </a:xfrm>
           <a:prstGeom prst="rect">
@@ -14686,7 +14686,7 @@
                   </a:extLst>
                 </a:hlinkClick>
               </a:rPr>
-              <a:t>Irrigation Department: reservoir status</a:t>
+              <a:t>Copernicus DEM (GLO-30)</a:t>
             </a:r>
             <a:pPr indent="0" marL="0">
               <a:buNone/>
@@ -14697,7 +14697,7 @@
                   <a:schemeClr val="accent6"/>
                 </a:solidFill>
               </a:rPr>
-              <a:t>  web page</a:t>
+              <a:t>  30 m elevation map</a:t>
             </a:r>
             <a:endParaRPr lang="en-US" sz="1250" dirty="0"/>
           </a:p>
@@ -14711,7 +14711,46 @@
         </p:nvSpPr>
         <p:spPr>
           <a:xfrm>
-            <a:off x="6415888" y="2697480"/>
+            <a:off x="6278728" y="1691640"/>
+            <a:ext cx="5364328" cy="329184"/>
+          </a:xfrm>
+          <a:prstGeom prst="rect">
+            <a:avLst/>
+          </a:prstGeom>
+          <a:noFill/>
+          <a:ln/>
+        </p:spPr>
+        <p:txBody>
+          <a:bodyPr wrap="square" lIns="0" tIns="0" rIns="0" bIns="0" rtlCol="0" anchor="ctr"/>
+          <a:lstStyle/>
+          <a:p>
+            <a:pPr indent="0" marL="0">
+              <a:buNone/>
+            </a:pPr>
+            <a:r>
+              <a:rPr lang="en-US" sz="1500" dirty="0">
+                <a:solidFill>
+                  <a:schemeClr val="tx1"/>
+                </a:solidFill>
+                <a:latin typeface="+mj-lt" pitchFamily="34" charset="0"/>
+                <a:ea typeface="+mj-lt" pitchFamily="34" charset="-122"/>
+                <a:cs typeface="+mj-lt" pitchFamily="34" charset="-120"/>
+              </a:rPr>
+              <a:t>Ground truth</a:t>
+            </a:r>
+            <a:endParaRPr lang="en-US" sz="1500" dirty="0"/>
+          </a:p>
+        </p:txBody>
+      </p:sp>
+      <p:sp>
+        <p:nvSpPr>
+          <p:cNvPr id="18" name="Text 16"/>
+          <p:cNvSpPr txBox="1"/>
+          <p:nvPr/>
+        </p:nvSpPr>
+        <p:spPr>
+          <a:xfrm>
+            <a:off x="6415888" y="2075688"/>
             <a:ext cx="5227168" cy="292608"/>
           </a:xfrm>
           <a:prstGeom prst="rect">
@@ -14740,7 +14779,7 @@
                   </a:extLst>
                 </a:hlinkClick>
               </a:rPr>
-              <a:t>Irrigation Department: reservoir map layer</a:t>
+              <a:t>Irrigation Department: reservoir water level</a:t>
             </a:r>
             <a:pPr indent="0" marL="0">
               <a:buNone/>
@@ -14751,7 +14790,7 @@
                   <a:schemeClr val="accent6"/>
                 </a:solidFill>
               </a:rPr>
-              <a:t>  full supply levels</a:t>
+              <a:t>  the daily sheet</a:t>
             </a:r>
             <a:endParaRPr lang="en-US" sz="1250" dirty="0"/>
           </a:p>
@@ -14759,13 +14798,13 @@
       </p:sp>
       <p:sp>
         <p:nvSpPr>
-          <p:cNvPr id="18" name="Text 16"/>
-          <p:cNvSpPr txBox="1"/>
-          <p:nvPr/>
-        </p:nvSpPr>
-        <p:spPr>
-          <a:xfrm>
-            <a:off x="6415888" y="3008376"/>
+          <p:cNvPr id="19" name="Text 17"/>
+          <p:cNvSpPr txBox="1"/>
+          <p:nvPr/>
+        </p:nvSpPr>
+        <p:spPr>
+          <a:xfrm>
+            <a:off x="6415888" y="2386584"/>
             <a:ext cx="5227168" cy="292608"/>
           </a:xfrm>
           <a:prstGeom prst="rect">
@@ -14794,7 +14833,7 @@
                   </a:extLst>
                 </a:hlinkClick>
               </a:rPr>
-              <a:t>Kanhindawewa drone survey</a:t>
+              <a:t>Irrigation Department: reservoir status</a:t>
             </a:r>
             <a:pPr indent="0" marL="0">
               <a:buNone/>
@@ -14805,7 +14844,7 @@
                   <a:schemeClr val="accent6"/>
                 </a:solidFill>
               </a:rPr>
-              <a:t>  area and capacity every 1 ft (PDF)</a:t>
+              <a:t>  web page</a:t>
             </a:r>
             <a:endParaRPr lang="en-US" sz="1250" dirty="0"/>
           </a:p>
@@ -14813,13 +14852,13 @@
       </p:sp>
       <p:sp>
         <p:nvSpPr>
-          <p:cNvPr id="19" name="Text 17"/>
-          <p:cNvSpPr txBox="1"/>
-          <p:nvPr/>
-        </p:nvSpPr>
-        <p:spPr>
-          <a:xfrm>
-            <a:off x="6415888" y="3319272"/>
+          <p:cNvPr id="20" name="Text 18"/>
+          <p:cNvSpPr txBox="1"/>
+          <p:nvPr/>
+        </p:nvSpPr>
+        <p:spPr>
+          <a:xfrm>
+            <a:off x="6415888" y="2697480"/>
             <a:ext cx="5227168" cy="292608"/>
           </a:xfrm>
           <a:prstGeom prst="rect">
@@ -14848,7 +14887,7 @@
                   </a:extLst>
                 </a:hlinkClick>
               </a:rPr>
-              <a:t>Mahaweli Authority: reservoir status reports</a:t>
+              <a:t>Irrigation Department: reservoir map layer</a:t>
             </a:r>
             <a:pPr indent="0" marL="0">
               <a:buNone/>
@@ -14859,7 +14898,7 @@
                   <a:schemeClr val="accent6"/>
                 </a:solidFill>
               </a:rPr>
-              <a:t>  daily levels</a:t>
+              <a:t>  full supply levels</a:t>
             </a:r>
             <a:endParaRPr lang="en-US" sz="1250" dirty="0"/>
           </a:p>
@@ -14867,52 +14906,13 @@
       </p:sp>
       <p:sp>
         <p:nvSpPr>
-          <p:cNvPr id="20" name="Text 18"/>
-          <p:cNvSpPr txBox="1"/>
-          <p:nvPr/>
-        </p:nvSpPr>
-        <p:spPr>
-          <a:xfrm>
-            <a:off x="6278728" y="3776472"/>
-            <a:ext cx="5364328" cy="329184"/>
-          </a:xfrm>
-          <a:prstGeom prst="rect">
-            <a:avLst/>
-          </a:prstGeom>
-          <a:noFill/>
-          <a:ln/>
-        </p:spPr>
-        <p:txBody>
-          <a:bodyPr wrap="square" lIns="0" tIns="0" rIns="0" bIns="0" rtlCol="0" anchor="ctr"/>
-          <a:lstStyle/>
-          <a:p>
-            <a:pPr indent="0" marL="0">
-              <a:buNone/>
-            </a:pPr>
-            <a:r>
-              <a:rPr lang="en-US" sz="1500" dirty="0">
-                <a:solidFill>
-                  <a:schemeClr val="tx1"/>
-                </a:solidFill>
-                <a:latin typeface="+mj-lt" pitchFamily="34" charset="0"/>
-                <a:ea typeface="+mj-lt" pitchFamily="34" charset="-122"/>
-                <a:cs typeface="+mj-lt" pitchFamily="34" charset="-120"/>
-              </a:rPr>
-              <a:t>Weather (for the forecast)</a:t>
-            </a:r>
-            <a:endParaRPr lang="en-US" sz="1500" dirty="0"/>
-          </a:p>
-        </p:txBody>
-      </p:sp>
-      <p:sp>
-        <p:nvSpPr>
           <p:cNvPr id="21" name="Text 19"/>
           <p:cNvSpPr txBox="1"/>
           <p:nvPr/>
         </p:nvSpPr>
         <p:spPr>
           <a:xfrm>
-            <a:off x="6415888" y="4160520"/>
+            <a:off x="6415888" y="3008376"/>
             <a:ext cx="5227168" cy="292608"/>
           </a:xfrm>
           <a:prstGeom prst="rect">
@@ -14941,7 +14941,7 @@
                   </a:extLst>
                 </a:hlinkClick>
               </a:rPr>
-              <a:t>CHIRPS</a:t>
+              <a:t>Kanhindawewa drone survey</a:t>
             </a:r>
             <a:pPr indent="0" marL="0">
               <a:buNone/>
@@ -14952,7 +14952,7 @@
                   <a:schemeClr val="accent6"/>
                 </a:solidFill>
               </a:rPr>
-              <a:t>  daily rainfall</a:t>
+              <a:t>  area and capacity every 1 ft (PDF)</a:t>
             </a:r>
             <a:endParaRPr lang="en-US" sz="1250" dirty="0"/>
           </a:p>
@@ -14966,7 +14966,7 @@
         </p:nvSpPr>
         <p:spPr>
           <a:xfrm>
-            <a:off x="6415888" y="4471416"/>
+            <a:off x="6415888" y="3319272"/>
             <a:ext cx="5227168" cy="292608"/>
           </a:xfrm>
           <a:prstGeom prst="rect">
@@ -14995,7 +14995,7 @@
                   </a:extLst>
                 </a:hlinkClick>
               </a:rPr>
-              <a:t>ERA5</a:t>
+              <a:t>Mahaweli Authority: reservoir status reports</a:t>
             </a:r>
             <a:pPr indent="0" marL="0">
               <a:buNone/>
@@ -15006,7 +15006,7 @@
                   <a:schemeClr val="accent6"/>
                 </a:solidFill>
               </a:rPr>
-              <a:t>  weather, for evaporation</a:t>
+              <a:t>  daily levels</a:t>
             </a:r>
             <a:endParaRPr lang="en-US" sz="1250" dirty="0"/>
           </a:p>
@@ -15020,7 +15020,7 @@
         </p:nvSpPr>
         <p:spPr>
           <a:xfrm>
-            <a:off x="6278728" y="4928616"/>
+            <a:off x="6278728" y="3776472"/>
             <a:ext cx="5364328" cy="329184"/>
           </a:xfrm>
           <a:prstGeom prst="rect">
@@ -15045,6 +15045,207 @@
                 <a:ea typeface="+mj-lt" pitchFamily="34" charset="-122"/>
                 <a:cs typeface="+mj-lt" pitchFamily="34" charset="-120"/>
               </a:rPr>
+              <a:t>Weather (for the forecast)</a:t>
+            </a:r>
+            <a:endParaRPr lang="en-US" sz="1500" dirty="0"/>
+          </a:p>
+        </p:txBody>
+      </p:sp>
+      <p:sp>
+        <p:nvSpPr>
+          <p:cNvPr id="24" name="Text 22"/>
+          <p:cNvSpPr txBox="1"/>
+          <p:nvPr/>
+        </p:nvSpPr>
+        <p:spPr>
+          <a:xfrm>
+            <a:off x="6415888" y="4160520"/>
+            <a:ext cx="5227168" cy="292608"/>
+          </a:xfrm>
+          <a:prstGeom prst="rect">
+            <a:avLst/>
+          </a:prstGeom>
+          <a:noFill/>
+          <a:ln/>
+        </p:spPr>
+        <p:txBody>
+          <a:bodyPr wrap="square" lIns="0" tIns="0" rIns="0" bIns="0" rtlCol="0" anchor="ctr"/>
+          <a:lstStyle/>
+          <a:p>
+            <a:pPr indent="0" marL="0">
+              <a:buNone/>
+            </a:pPr>
+            <a:r>
+              <a:rPr lang="en-US" sz="1250" b="1" u="sng" dirty="0">
+                <a:solidFill>
+                  <a:schemeClr val="accent1"/>
+                </a:solidFill>
+                <a:hlinkClick r:id="rId16" invalidUrl="" action="" tgtFrame="" tooltip="" history="1" highlightClick="0" endSnd="0">
+                  <a:extLst>
+                    <a:ext uri="{A12FA001-AC4F-418D-AE19-62706E023703}">
+                      <ahyp:hlinkClr xmlns:ahyp="http://schemas.microsoft.com/office/drawing/2018/hyperlinkcolor" val="tx"/>
+                    </a:ext>
+                  </a:extLst>
+                </a:hlinkClick>
+              </a:rPr>
+              <a:t>GPM IMERG</a:t>
+            </a:r>
+            <a:pPr indent="0" marL="0">
+              <a:buNone/>
+            </a:pPr>
+            <a:r>
+              <a:rPr lang="en-US" sz="1250" dirty="0">
+                <a:solidFill>
+                  <a:schemeClr val="accent6"/>
+                </a:solidFill>
+              </a:rPr>
+              <a:t>  daily rainfall</a:t>
+            </a:r>
+            <a:endParaRPr lang="en-US" sz="1250" dirty="0"/>
+          </a:p>
+        </p:txBody>
+      </p:sp>
+      <p:sp>
+        <p:nvSpPr>
+          <p:cNvPr id="25" name="Text 23"/>
+          <p:cNvSpPr txBox="1"/>
+          <p:nvPr/>
+        </p:nvSpPr>
+        <p:spPr>
+          <a:xfrm>
+            <a:off x="6415888" y="4471416"/>
+            <a:ext cx="5227168" cy="292608"/>
+          </a:xfrm>
+          <a:prstGeom prst="rect">
+            <a:avLst/>
+          </a:prstGeom>
+          <a:noFill/>
+          <a:ln/>
+        </p:spPr>
+        <p:txBody>
+          <a:bodyPr wrap="square" lIns="0" tIns="0" rIns="0" bIns="0" rtlCol="0" anchor="ctr"/>
+          <a:lstStyle/>
+          <a:p>
+            <a:pPr indent="0" marL="0">
+              <a:buNone/>
+            </a:pPr>
+            <a:r>
+              <a:rPr lang="en-US" sz="1250" b="1" u="sng" dirty="0">
+                <a:solidFill>
+                  <a:schemeClr val="accent1"/>
+                </a:solidFill>
+                <a:hlinkClick r:id="rId17" invalidUrl="" action="" tgtFrame="" tooltip="" history="1" highlightClick="0" endSnd="0">
+                  <a:extLst>
+                    <a:ext uri="{A12FA001-AC4F-418D-AE19-62706E023703}">
+                      <ahyp:hlinkClr xmlns:ahyp="http://schemas.microsoft.com/office/drawing/2018/hyperlinkcolor" val="tx"/>
+                    </a:ext>
+                  </a:extLst>
+                </a:hlinkClick>
+              </a:rPr>
+              <a:t>CHIRPS</a:t>
+            </a:r>
+            <a:pPr indent="0" marL="0">
+              <a:buNone/>
+            </a:pPr>
+            <a:r>
+              <a:rPr lang="en-US" sz="1250" dirty="0">
+                <a:solidFill>
+                  <a:schemeClr val="accent6"/>
+                </a:solidFill>
+              </a:rPr>
+              <a:t>  monthly rainfall checks</a:t>
+            </a:r>
+            <a:endParaRPr lang="en-US" sz="1250" dirty="0"/>
+          </a:p>
+        </p:txBody>
+      </p:sp>
+      <p:sp>
+        <p:nvSpPr>
+          <p:cNvPr id="26" name="Text 24"/>
+          <p:cNvSpPr txBox="1"/>
+          <p:nvPr/>
+        </p:nvSpPr>
+        <p:spPr>
+          <a:xfrm>
+            <a:off x="6415888" y="4782312"/>
+            <a:ext cx="5227168" cy="292608"/>
+          </a:xfrm>
+          <a:prstGeom prst="rect">
+            <a:avLst/>
+          </a:prstGeom>
+          <a:noFill/>
+          <a:ln/>
+        </p:spPr>
+        <p:txBody>
+          <a:bodyPr wrap="square" lIns="0" tIns="0" rIns="0" bIns="0" rtlCol="0" anchor="ctr"/>
+          <a:lstStyle/>
+          <a:p>
+            <a:pPr indent="0" marL="0">
+              <a:buNone/>
+            </a:pPr>
+            <a:r>
+              <a:rPr lang="en-US" sz="1250" b="1" u="sng" dirty="0">
+                <a:solidFill>
+                  <a:schemeClr val="accent1"/>
+                </a:solidFill>
+                <a:hlinkClick r:id="rId18" invalidUrl="" action="" tgtFrame="" tooltip="" history="1" highlightClick="0" endSnd="0">
+                  <a:extLst>
+                    <a:ext uri="{A12FA001-AC4F-418D-AE19-62706E023703}">
+                      <ahyp:hlinkClr xmlns:ahyp="http://schemas.microsoft.com/office/drawing/2018/hyperlinkcolor" val="tx"/>
+                    </a:ext>
+                  </a:extLst>
+                </a:hlinkClick>
+              </a:rPr>
+              <a:t>ERA5</a:t>
+            </a:r>
+            <a:pPr indent="0" marL="0">
+              <a:buNone/>
+            </a:pPr>
+            <a:r>
+              <a:rPr lang="en-US" sz="1250" dirty="0">
+                <a:solidFill>
+                  <a:schemeClr val="accent6"/>
+                </a:solidFill>
+              </a:rPr>
+              <a:t>  weather, for evaporation</a:t>
+            </a:r>
+            <a:endParaRPr lang="en-US" sz="1250" dirty="0"/>
+          </a:p>
+        </p:txBody>
+      </p:sp>
+      <p:sp>
+        <p:nvSpPr>
+          <p:cNvPr id="27" name="Text 25"/>
+          <p:cNvSpPr txBox="1"/>
+          <p:nvPr/>
+        </p:nvSpPr>
+        <p:spPr>
+          <a:xfrm>
+            <a:off x="6278728" y="5239512"/>
+            <a:ext cx="5364328" cy="329184"/>
+          </a:xfrm>
+          <a:prstGeom prst="rect">
+            <a:avLst/>
+          </a:prstGeom>
+          <a:noFill/>
+          <a:ln/>
+        </p:spPr>
+        <p:txBody>
+          <a:bodyPr wrap="square" lIns="0" tIns="0" rIns="0" bIns="0" rtlCol="0" anchor="ctr"/>
+          <a:lstStyle/>
+          <a:p>
+            <a:pPr indent="0" marL="0">
+              <a:buNone/>
+            </a:pPr>
+            <a:r>
+              <a:rPr lang="en-US" sz="1500" dirty="0">
+                <a:solidFill>
+                  <a:schemeClr val="tx1"/>
+                </a:solidFill>
+                <a:latin typeface="+mj-lt" pitchFamily="34" charset="0"/>
+                <a:ea typeface="+mj-lt" pitchFamily="34" charset="-122"/>
+                <a:cs typeface="+mj-lt" pitchFamily="34" charset="-120"/>
+              </a:rPr>
               <a:t>Our work</a:t>
             </a:r>
             <a:endParaRPr lang="en-US" sz="1500" dirty="0"/>
@@ -15053,13 +15254,13 @@
       </p:sp>
       <p:sp>
         <p:nvSpPr>
-          <p:cNvPr id="24" name="Text 22"/>
-          <p:cNvSpPr txBox="1"/>
-          <p:nvPr/>
-        </p:nvSpPr>
-        <p:spPr>
-          <a:xfrm>
-            <a:off x="6415888" y="5312664"/>
+          <p:cNvPr id="28" name="Text 26"/>
+          <p:cNvSpPr txBox="1"/>
+          <p:nvPr/>
+        </p:nvSpPr>
+        <p:spPr>
+          <a:xfrm>
+            <a:off x="6415888" y="5623560"/>
             <a:ext cx="5227168" cy="292608"/>
           </a:xfrm>
           <a:prstGeom prst="rect">
@@ -15080,7 +15281,7 @@
                 <a:solidFill>
                   <a:schemeClr val="accent1"/>
                 </a:solidFill>
-                <a:hlinkClick r:id="rId16" invalidUrl="" action="" tgtFrame="" tooltip="" history="1" highlightClick="0" endSnd="0">
+                <a:hlinkClick r:id="rId19" invalidUrl="" action="" tgtFrame="" tooltip="" history="1" highlightClick="0" endSnd="0">
                   <a:extLst>
                     <a:ext uri="{A12FA001-AC4F-418D-AE19-62706E023703}">
                       <ahyp:hlinkClr xmlns:ahyp="http://schemas.microsoft.com/office/drawing/2018/hyperlinkcolor" val="tx"/>

</xml_diff>